<commit_message>
fix(signalr): review fixes — offline hang, reconnect wording, timer chain, no ProtoLab in demo
Co-Authored-By: Claude Sonnet 5.5 <noreply@anthropic.com>
</commit_message>
<xml_diff>
--- a/SignalR/presentation/SignalR - More Than WebSocket.pptx
+++ b/SignalR/presentation/SignalR - More Than WebSocket.pptx
@@ -26691,7 +26691,7 @@
           <p:spPr>
             <a:xfrm>
               <a:off x="982218" y="5816600"/>
-              <a:ext cx="8640626" cy="322707"/>
+              <a:ext cx="9330275" cy="322707"/>
             </a:xfrm>
             <a:prstGeom prst="rect">
               <a:avLst/>
@@ -26783,7 +26783,7 @@
                   <a:ea typeface="+mn-ea"/>
                   <a:cs typeface="+mn-cs"/>
                 </a:rPr>
-                <a:t>onreconnected → banner hides</a:t>
+                <a:t>onreconnected → “Refresh your page”</a:t>
               </a:r>
             </a:p>
           </p:txBody>

</xml_diff>

<commit_message>
chore(bidlab): demo covers connect and bid only, drop scenario dropdown and helper text; clean workspace
Co-Authored-By: Claude Sonnet 5.5 <noreply@anthropic.com>
</commit_message>
<xml_diff>
--- a/SignalR/presentation/SignalR - More Than WebSocket.pptx
+++ b/SignalR/presentation/SignalR - More Than WebSocket.pptx
@@ -11892,7 +11892,7 @@
         <p:spPr>
           <a:xfrm>
             <a:off x="609600" y="3543300"/>
-            <a:ext cx="3009900" cy="762000"/>
+            <a:ext cx="4000500" cy="762000"/>
           </a:xfrm>
           <a:prstGeom prst="chevron">
             <a:avLst/>
@@ -11915,8 +11915,8 @@
         </p:nvSpPr>
         <p:spPr>
           <a:xfrm>
-            <a:off x="3238500" y="3543300"/>
-            <a:ext cx="3009900" cy="762000"/>
+            <a:off x="4229100" y="3543300"/>
+            <a:ext cx="4000500" cy="762000"/>
           </a:xfrm>
           <a:prstGeom prst="chevron">
             <a:avLst/>
@@ -11939,32 +11939,8 @@
         </p:nvSpPr>
         <p:spPr>
           <a:xfrm>
-            <a:off x="5867400" y="3543300"/>
-            <a:ext cx="3009900" cy="762000"/>
-          </a:xfrm>
-          <a:prstGeom prst="chevron">
-            <a:avLst/>
-          </a:prstGeom>
-          <a:solidFill>
-            <a:schemeClr val="lt2"/>
-          </a:solidFill>
-          <a:ln w="14288">
-            <a:solidFill>
-              <a:schemeClr val="accent2"/>
-            </a:solidFill>
-          </a:ln>
-        </p:spPr>
-      </p:sp>
-      <p:sp>
-        <p:nvSpPr>
-          <p:cNvPr id="10" name="Freeform 10"/>
-          <p:cNvSpPr/>
-          <p:nvPr/>
-        </p:nvSpPr>
-        <p:spPr>
-          <a:xfrm>
-            <a:off x="8496300" y="3543300"/>
-            <a:ext cx="3009900" cy="762000"/>
+            <a:off x="7848600" y="3543300"/>
+            <a:ext cx="3733800" cy="762000"/>
           </a:xfrm>
           <a:prstGeom prst="chevron">
             <a:avLst/>
@@ -11981,41 +11957,41 @@
       </p:sp>
       <p:grpSp>
         <p:nvGrpSpPr>
-          <p:cNvPr id="21" name="scene-labels"/>
+          <p:cNvPr id="18" name="scene-labels"/>
           <p:cNvGrpSpPr/>
           <p:nvPr/>
         </p:nvGrpSpPr>
         <p:grpSpPr>
           <a:xfrm>
-            <a:off x="1091030" y="3797300"/>
-            <a:ext cx="9599041" cy="991870"/>
-            <a:chOff x="1091030" y="3797300"/>
-            <a:chExt cx="9599041" cy="991870"/>
+            <a:off x="1586330" y="3797300"/>
+            <a:ext cx="8999202" cy="991870"/>
+            <a:chOff x="1586330" y="3797300"/>
+            <a:chExt cx="8999202" cy="991870"/>
           </a:xfrm>
         </p:grpSpPr>
         <p:grpSp>
           <p:nvGrpSpPr>
-            <p:cNvPr id="15" name="Group 15"/>
+            <p:cNvPr id="13" name="Group 13"/>
             <p:cNvGrpSpPr/>
             <p:nvPr/>
           </p:nvGrpSpPr>
           <p:grpSpPr>
             <a:xfrm>
-              <a:off x="1517988" y="3797300"/>
-              <a:ext cx="9172083" cy="322707"/>
-              <a:chOff x="1517988" y="3797300"/>
-              <a:chExt cx="9172083" cy="322707"/>
+              <a:off x="2013288" y="3797300"/>
+              <a:ext cx="8391033" cy="322707"/>
+              <a:chOff x="2013288" y="3797300"/>
+              <a:chExt cx="8391033" cy="322707"/>
             </a:xfrm>
           </p:grpSpPr>
           <p:sp>
             <p:nvSpPr>
-              <p:cNvPr id="11" name="TextBox 11"/>
+              <p:cNvPr id="10" name="TextBox 10"/>
               <p:cNvSpPr txBox="1"/>
               <p:nvPr/>
             </p:nvSpPr>
             <p:spPr>
               <a:xfrm>
-                <a:off x="1517988" y="3797300"/>
+                <a:off x="2013288" y="3797300"/>
                 <a:ext cx="1193123" cy="322707"/>
               </a:xfrm>
               <a:prstGeom prst="rect">
@@ -12049,13 +12025,13 @@
           </p:sp>
           <p:sp>
             <p:nvSpPr>
-              <p:cNvPr id="12" name="TextBox 12"/>
+              <p:cNvPr id="11" name="TextBox 11"/>
               <p:cNvSpPr txBox="1"/>
               <p:nvPr/>
             </p:nvSpPr>
             <p:spPr>
               <a:xfrm>
-                <a:off x="4402115" y="3797300"/>
+                <a:off x="5888015" y="3797300"/>
                 <a:ext cx="682670" cy="322707"/>
               </a:xfrm>
               <a:prstGeom prst="rect">
@@ -12089,53 +12065,13 @@
           </p:sp>
           <p:sp>
             <p:nvSpPr>
-              <p:cNvPr id="13" name="TextBox 13"/>
+              <p:cNvPr id="12" name="TextBox 12"/>
               <p:cNvSpPr txBox="1"/>
               <p:nvPr/>
             </p:nvSpPr>
             <p:spPr>
               <a:xfrm>
-                <a:off x="6775989" y="3797300"/>
-                <a:ext cx="1192723" cy="322707"/>
-              </a:xfrm>
-              <a:prstGeom prst="rect">
-                <a:avLst/>
-              </a:prstGeom>
-              <a:noFill/>
-              <a:ln>
-                <a:noFill/>
-              </a:ln>
-            </p:spPr>
-            <p:txBody>
-              <a:bodyPr wrap="none" lIns="0" tIns="0" rIns="0" bIns="0" anchor="t" anchorCtr="0">
-                <a:spAutoFit/>
-              </a:bodyPr>
-              <a:lstStyle/>
-              <a:p>
-                <a:pPr algn="ctr"/>
-                <a:r>
-                  <a:rPr lang="en" sz="1650" b="1" dirty="0">
-                    <a:solidFill>
-                      <a:schemeClr val="accent1"/>
-                    </a:solidFill>
-                    <a:latin typeface="+mn-lt"/>
-                    <a:ea typeface="+mn-ea"/>
-                    <a:cs typeface="+mn-cs"/>
-                  </a:rPr>
-                  <a:t>3 · Max bid</a:t>
-                </a:r>
-              </a:p>
-            </p:txBody>
-          </p:sp>
-          <p:sp>
-            <p:nvSpPr>
-              <p:cNvPr id="14" name="TextBox 14"/>
-              <p:cNvSpPr txBox="1"/>
-              <p:nvPr/>
-            </p:nvSpPr>
-            <p:spPr>
-              <a:xfrm>
-                <a:off x="9312428" y="3797300"/>
+                <a:off x="9026678" y="3797300"/>
                 <a:ext cx="1377643" cy="322707"/>
               </a:xfrm>
               <a:prstGeom prst="rect">
@@ -12162,7 +12098,7 @@
                     <a:ea typeface="+mn-ea"/>
                     <a:cs typeface="+mn-cs"/>
                   </a:rPr>
-                  <a:t>4 · Go offline</a:t>
+                  <a:t>3 · Go offline</a:t>
                 </a:r>
               </a:p>
             </p:txBody>
@@ -12170,27 +12106,27 @@
         </p:grpSp>
         <p:grpSp>
           <p:nvGrpSpPr>
-            <p:cNvPr id="20" name="Group 20"/>
+            <p:cNvPr id="17" name="Group 17"/>
             <p:cNvGrpSpPr/>
             <p:nvPr/>
           </p:nvGrpSpPr>
           <p:grpSpPr>
             <a:xfrm>
-              <a:off x="1091030" y="4495800"/>
-              <a:ext cx="9594195" cy="293370"/>
-              <a:chOff x="1091030" y="4495800"/>
-              <a:chExt cx="9594195" cy="293370"/>
+              <a:off x="1586330" y="4495800"/>
+              <a:ext cx="8999202" cy="293370"/>
+              <a:chOff x="1586330" y="4495800"/>
+              <a:chExt cx="8999202" cy="293370"/>
             </a:xfrm>
           </p:grpSpPr>
           <p:sp>
             <p:nvSpPr>
-              <p:cNvPr id="16" name="TextBox 16"/>
+              <p:cNvPr id="14" name="TextBox 14"/>
               <p:cNvSpPr txBox="1"/>
               <p:nvPr/>
             </p:nvSpPr>
             <p:spPr>
               <a:xfrm>
-                <a:off x="1091030" y="4495800"/>
+                <a:off x="1586330" y="4495800"/>
                 <a:ext cx="2047039" cy="293370"/>
               </a:xfrm>
               <a:prstGeom prst="rect">
@@ -12224,13 +12160,13 @@
           </p:sp>
           <p:sp>
             <p:nvSpPr>
-              <p:cNvPr id="17" name="TextBox 17"/>
+              <p:cNvPr id="15" name="TextBox 15"/>
               <p:cNvSpPr txBox="1"/>
               <p:nvPr/>
             </p:nvSpPr>
             <p:spPr>
               <a:xfrm>
-                <a:off x="3635678" y="4495800"/>
+                <a:off x="5121578" y="4495800"/>
                 <a:ext cx="2215543" cy="293370"/>
               </a:xfrm>
               <a:prstGeom prst="rect">
@@ -12264,14 +12200,14 @@
           </p:sp>
           <p:sp>
             <p:nvSpPr>
-              <p:cNvPr id="18" name="TextBox 18"/>
+              <p:cNvPr id="16" name="TextBox 16"/>
               <p:cNvSpPr txBox="1"/>
               <p:nvPr/>
             </p:nvSpPr>
             <p:spPr>
               <a:xfrm>
-                <a:off x="6357800" y="4495800"/>
-                <a:ext cx="2029101" cy="293370"/>
+                <a:off x="8845467" y="4495800"/>
+                <a:ext cx="1740065" cy="293370"/>
               </a:xfrm>
               <a:prstGeom prst="rect">
                 <a:avLst/>
@@ -12297,47 +12233,7 @@
                     <a:ea typeface="+mn-ea"/>
                     <a:cs typeface="+mn-cs"/>
                   </a:rPr>
-                  <a:t>Anna is outbid at once</a:t>
-                </a:r>
-              </a:p>
-            </p:txBody>
-          </p:sp>
-          <p:sp>
-            <p:nvSpPr>
-              <p:cNvPr id="19" name="TextBox 19"/>
-              <p:cNvSpPr txBox="1"/>
-              <p:nvPr/>
-            </p:nvSpPr>
-            <p:spPr>
-              <a:xfrm>
-                <a:off x="9317276" y="4495800"/>
-                <a:ext cx="1367949" cy="293370"/>
-              </a:xfrm>
-              <a:prstGeom prst="rect">
-                <a:avLst/>
-              </a:prstGeom>
-              <a:noFill/>
-              <a:ln>
-                <a:noFill/>
-              </a:ln>
-            </p:spPr>
-            <p:txBody>
-              <a:bodyPr wrap="none" lIns="0" tIns="0" rIns="0" bIns="0" anchor="t" anchorCtr="0">
-                <a:spAutoFit/>
-              </a:bodyPr>
-              <a:lstStyle/>
-              <a:p>
-                <a:pPr algn="ctr"/>
-                <a:r>
-                  <a:rPr lang="en" sz="1500" dirty="0">
-                    <a:solidFill>
-                      <a:schemeClr val="accent5"/>
-                    </a:solidFill>
-                    <a:latin typeface="+mn-lt"/>
-                    <a:ea typeface="+mn-ea"/>
-                    <a:cs typeface="+mn-cs"/>
-                  </a:rPr>
-                  <a:t>retry 0 · 2 · 10 s</a:t>
+                  <a:t>retry 0 · 2 · 10 · 30 s</a:t>
                 </a:r>
               </a:p>
             </p:txBody>
@@ -12346,7 +12242,7 @@
       </p:grpSp>
       <p:grpSp>
         <p:nvGrpSpPr>
-          <p:cNvPr id="28" name="demo-link"/>
+          <p:cNvPr id="25" name="demo-link"/>
           <p:cNvGrpSpPr/>
           <p:nvPr/>
         </p:nvGrpSpPr>
@@ -12360,7 +12256,7 @@
         </p:grpSpPr>
         <p:grpSp>
           <p:nvGrpSpPr>
-            <p:cNvPr id="25" name="Group 25"/>
+            <p:cNvPr id="22" name="Group 22"/>
             <p:cNvGrpSpPr/>
             <p:nvPr/>
           </p:nvGrpSpPr>
@@ -12374,7 +12270,7 @@
           </p:grpSpPr>
           <p:sp>
             <p:nvSpPr>
-              <p:cNvPr id="22" name="Freeform 22"/>
+              <p:cNvPr id="19" name="Freeform 19"/>
               <p:cNvSpPr/>
               <p:nvPr/>
             </p:nvSpPr>
@@ -12410,7 +12306,7 @@
           </p:sp>
           <p:sp>
             <p:nvSpPr>
-              <p:cNvPr id="23" name="Freeform 23"/>
+              <p:cNvPr id="20" name="Freeform 20"/>
               <p:cNvSpPr/>
               <p:nvPr/>
             </p:nvSpPr>
@@ -12475,7 +12371,7 @@
           </p:sp>
           <p:sp>
             <p:nvSpPr>
-              <p:cNvPr id="24" name="Freeform 24"/>
+              <p:cNvPr id="21" name="Freeform 21"/>
               <p:cNvSpPr/>
               <p:nvPr/>
             </p:nvSpPr>
@@ -12512,7 +12408,7 @@
         </p:grpSp>
         <p:sp>
           <p:nvSpPr>
-            <p:cNvPr id="26" name="TextBox 26"/>
+            <p:cNvPr id="23" name="TextBox 23"/>
             <p:cNvSpPr txBox="1"/>
             <p:nvPr/>
           </p:nvSpPr>
@@ -12552,7 +12448,7 @@
         </p:sp>
         <p:sp>
           <p:nvSpPr>
-            <p:cNvPr id="27" name="TextBox 27"/>
+            <p:cNvPr id="24" name="TextBox 24"/>
             <p:cNvSpPr txBox="1"/>
             <p:nvPr/>
           </p:nvSpPr>

</xml_diff>